<commit_message>
Atualiza documento e apresentacao finais da A3
- documento: Apendice A sincronizado com o script unico; Apendice B
  (migragem separada) removido e Apendice C renomeado para B; sumario e
  referencias cruzadas ajustados;
- apresentacao: slide de encerramento com as entregas reais (DOCX, PPTX e
  .sql unico) e trigger BEFORE INSERT OR UPDATE no slide de DDL.
</commit_message>
<xml_diff>
--- a/entrega/ParkSim_A3_Apresentacao.pptx
+++ b/entrega/ParkSim_A3_Apresentacao.pptx
@@ -5814,7 +5814,7 @@
               </a:defRPr>
             </a:pPr>
             <a:r>
-              <a:t>CREATE TRIGGER trg_calcular_saida BEFORE UPDATE ON movimentacao</a:t>
+              <a:t>CREATE TRIGGER trg_calcular_saida BEFORE INSERT OR UPDATE ON movimentacao</a:t>
             </a:r>
           </a:p>
           <a:p>
@@ -9579,7 +9579,7 @@
               </a:defRPr>
             </a:pPr>
             <a:r>
-              <a:t>Entregas: documento de projeto (DOCX/PDF), apresentação (PPTX/PDF), diagramas e script .sql (DDL + DML + DQL) executável no Supabase.</a:t>
+              <a:t>Entregas: documento de projeto (DOCX, com os diagramas), apresentação (PPTX) e script .sql único (DDL + DML + DQL) executável no Supabase.</a:t>
             </a:r>
           </a:p>
         </p:txBody>

</xml_diff>

<commit_message>
Corrige layout da apresentacao (overflow e alinhamento)
- slide 14: bloco de codigo DDL nao cabia na caixa e invadia o rodape/roda
  da pagina: fonte ajustada para 10,5pt, caixa redimensionada acima do
  rodape e normAutofit como rede de seguranca;
- slides 11, 14, 15, 16 e 17: primeira linha dos blocos de codigo estava
  centrada (algn=ctr) e quebrava o alinhamento monoespacado;
- slide 22: tabela de encerramento tinha uma coluna vazia no meio;
  removida, ficando Integrante | RA.
</commit_message>
<xml_diff>
--- a/entrega/ParkSim_A3_Apresentacao.pptx
+++ b/entrega/ParkSim_A3_Apresentacao.pptx
@@ -3992,7 +3992,7 @@
           <a:bodyPr rtlCol="0" anchor="ctr" wrap="square" lIns="228600" tIns="164592"/>
           <a:lstStyle/>
           <a:p>
-            <a:pPr algn="ctr">
+            <a:pPr>
               <a:spcAft>
                 <a:spcPts val="100"/>
               </a:spcAft>
@@ -5449,7 +5449,7 @@
         <p:spPr>
           <a:xfrm>
             <a:off x="502920" y="1371600"/>
-            <a:ext cx="11183112" cy="5120640"/>
+            <a:ext cx="11183112" cy="4980000"/>
           </a:xfrm>
           <a:prstGeom prst="rect">
             <a:avLst/>
@@ -5479,14 +5479,16 @@
           </a:fontRef>
         </p:style>
         <p:txBody>
-          <a:bodyPr rtlCol="0" anchor="ctr" wrap="square" lIns="228600" tIns="164592"/>
-          <a:lstStyle/>
-          <a:p>
-            <a:pPr algn="ctr">
+          <a:bodyPr rtlCol="0" anchor="ctr" wrap="square" lIns="228600" tIns="164592">
+            <a:normAutofit/>
+          </a:bodyPr>
+          <a:lstStyle/>
+          <a:p>
+            <a:pPr>
               <a:spcAft>
                 <a:spcPts val="100"/>
               </a:spcAft>
-              <a:defRPr sz="1250">
+              <a:defRPr sz="1050">
                 <a:solidFill>
                   <a:srgbClr val="DFE8FF"/>
                 </a:solidFill>
@@ -5502,7 +5504,7 @@
               <a:spcAft>
                 <a:spcPts val="100"/>
               </a:spcAft>
-              <a:defRPr sz="1250">
+              <a:defRPr sz="1050">
                 <a:solidFill>
                   <a:srgbClr val="DFE8FF"/>
                 </a:solidFill>
@@ -5518,7 +5520,7 @@
               <a:spcAft>
                 <a:spcPts val="100"/>
               </a:spcAft>
-              <a:defRPr sz="1250">
+              <a:defRPr sz="1050">
                 <a:solidFill>
                   <a:srgbClr val="DFE8FF"/>
                 </a:solidFill>
@@ -5534,7 +5536,7 @@
               <a:spcAft>
                 <a:spcPts val="100"/>
               </a:spcAft>
-              <a:defRPr sz="1250">
+              <a:defRPr sz="1050">
                 <a:solidFill>
                   <a:srgbClr val="DFE8FF"/>
                 </a:solidFill>
@@ -5550,7 +5552,7 @@
               <a:spcAft>
                 <a:spcPts val="100"/>
               </a:spcAft>
-              <a:defRPr sz="1250">
+              <a:defRPr sz="1050">
                 <a:solidFill>
                   <a:srgbClr val="DFE8FF"/>
                 </a:solidFill>
@@ -5566,7 +5568,7 @@
               <a:spcAft>
                 <a:spcPts val="100"/>
               </a:spcAft>
-              <a:defRPr sz="1250">
+              <a:defRPr sz="1050">
                 <a:solidFill>
                   <a:srgbClr val="DFE8FF"/>
                 </a:solidFill>
@@ -5582,7 +5584,7 @@
               <a:spcAft>
                 <a:spcPts val="100"/>
               </a:spcAft>
-              <a:defRPr sz="1250">
+              <a:defRPr sz="1050">
                 <a:solidFill>
                   <a:srgbClr val="DFE8FF"/>
                 </a:solidFill>
@@ -5598,7 +5600,7 @@
               <a:spcAft>
                 <a:spcPts val="100"/>
               </a:spcAft>
-              <a:defRPr sz="1250">
+              <a:defRPr sz="1050">
                 <a:solidFill>
                   <a:srgbClr val="DFE8FF"/>
                 </a:solidFill>
@@ -5614,7 +5616,7 @@
               <a:spcAft>
                 <a:spcPts val="100"/>
               </a:spcAft>
-              <a:defRPr sz="1250">
+              <a:defRPr sz="1050">
                 <a:solidFill>
                   <a:srgbClr val="DFE8FF"/>
                 </a:solidFill>
@@ -5630,7 +5632,7 @@
               <a:spcAft>
                 <a:spcPts val="100"/>
               </a:spcAft>
-              <a:defRPr sz="1250">
+              <a:defRPr sz="1050">
                 <a:solidFill>
                   <a:srgbClr val="DFE8FF"/>
                 </a:solidFill>
@@ -5646,7 +5648,7 @@
               <a:spcAft>
                 <a:spcPts val="100"/>
               </a:spcAft>
-              <a:defRPr sz="1250">
+              <a:defRPr sz="1050">
                 <a:solidFill>
                   <a:srgbClr val="DFE8FF"/>
                 </a:solidFill>
@@ -5662,7 +5664,7 @@
               <a:spcAft>
                 <a:spcPts val="100"/>
               </a:spcAft>
-              <a:defRPr sz="1250">
+              <a:defRPr sz="1050">
                 <a:solidFill>
                   <a:srgbClr val="DFE8FF"/>
                 </a:solidFill>
@@ -5678,7 +5680,7 @@
               <a:spcAft>
                 <a:spcPts val="100"/>
               </a:spcAft>
-              <a:defRPr sz="1250">
+              <a:defRPr sz="1050">
                 <a:solidFill>
                   <a:srgbClr val="DFE8FF"/>
                 </a:solidFill>
@@ -5694,7 +5696,7 @@
               <a:spcAft>
                 <a:spcPts val="100"/>
               </a:spcAft>
-              <a:defRPr sz="1250">
+              <a:defRPr sz="1050">
                 <a:solidFill>
                   <a:srgbClr val="DFE8FF"/>
                 </a:solidFill>
@@ -5710,7 +5712,7 @@
               <a:spcAft>
                 <a:spcPts val="100"/>
               </a:spcAft>
-              <a:defRPr sz="1250">
+              <a:defRPr sz="1050">
                 <a:solidFill>
                   <a:srgbClr val="DFE8FF"/>
                 </a:solidFill>
@@ -5726,7 +5728,7 @@
               <a:spcAft>
                 <a:spcPts val="100"/>
               </a:spcAft>
-              <a:defRPr sz="1250">
+              <a:defRPr sz="1050">
                 <a:solidFill>
                   <a:srgbClr val="DFE8FF"/>
                 </a:solidFill>
@@ -5742,7 +5744,7 @@
               <a:spcAft>
                 <a:spcPts val="100"/>
               </a:spcAft>
-              <a:defRPr sz="1250">
+              <a:defRPr sz="1050">
                 <a:solidFill>
                   <a:srgbClr val="DFE8FF"/>
                 </a:solidFill>
@@ -5758,7 +5760,7 @@
               <a:spcAft>
                 <a:spcPts val="100"/>
               </a:spcAft>
-              <a:defRPr sz="1250">
+              <a:defRPr sz="1050">
                 <a:solidFill>
                   <a:srgbClr val="DFE8FF"/>
                 </a:solidFill>
@@ -5774,7 +5776,7 @@
               <a:spcAft>
                 <a:spcPts val="100"/>
               </a:spcAft>
-              <a:defRPr sz="1250">
+              <a:defRPr sz="1050">
                 <a:solidFill>
                   <a:srgbClr val="DFE8FF"/>
                 </a:solidFill>
@@ -5790,7 +5792,7 @@
               <a:spcAft>
                 <a:spcPts val="100"/>
               </a:spcAft>
-              <a:defRPr sz="1250">
+              <a:defRPr sz="1050">
                 <a:solidFill>
                   <a:srgbClr val="DFE8FF"/>
                 </a:solidFill>
@@ -5806,7 +5808,7 @@
               <a:spcAft>
                 <a:spcPts val="100"/>
               </a:spcAft>
-              <a:defRPr sz="1250">
+              <a:defRPr sz="1050">
                 <a:solidFill>
                   <a:srgbClr val="DFE8FF"/>
                 </a:solidFill>
@@ -5822,7 +5824,7 @@
               <a:spcAft>
                 <a:spcPts val="100"/>
               </a:spcAft>
-              <a:defRPr sz="1250">
+              <a:defRPr sz="1050">
                 <a:solidFill>
                   <a:srgbClr val="DFE8FF"/>
                 </a:solidFill>
@@ -5838,7 +5840,7 @@
               <a:spcAft>
                 <a:spcPts val="100"/>
               </a:spcAft>
-              <a:defRPr sz="1250">
+              <a:defRPr sz="1050">
                 <a:solidFill>
                   <a:srgbClr val="DFE8FF"/>
                 </a:solidFill>
@@ -5854,7 +5856,7 @@
               <a:spcAft>
                 <a:spcPts val="100"/>
               </a:spcAft>
-              <a:defRPr sz="1250">
+              <a:defRPr sz="1050">
                 <a:solidFill>
                   <a:srgbClr val="DFE8FF"/>
                 </a:solidFill>
@@ -5870,7 +5872,7 @@
               <a:spcAft>
                 <a:spcPts val="100"/>
               </a:spcAft>
-              <a:defRPr sz="1250">
+              <a:defRPr sz="1050">
                 <a:solidFill>
                   <a:srgbClr val="DFE8FF"/>
                 </a:solidFill>
@@ -5886,7 +5888,7 @@
               <a:spcAft>
                 <a:spcPts val="100"/>
               </a:spcAft>
-              <a:defRPr sz="1250">
+              <a:defRPr sz="1050">
                 <a:solidFill>
                   <a:srgbClr val="DFE8FF"/>
                 </a:solidFill>
@@ -5902,7 +5904,7 @@
               <a:spcAft>
                 <a:spcPts val="100"/>
               </a:spcAft>
-              <a:defRPr sz="1250">
+              <a:defRPr sz="1050">
                 <a:solidFill>
                   <a:srgbClr val="DFE8FF"/>
                 </a:solidFill>
@@ -5918,7 +5920,7 @@
               <a:spcAft>
                 <a:spcPts val="100"/>
               </a:spcAft>
-              <a:defRPr sz="1250">
+              <a:defRPr sz="1050">
                 <a:solidFill>
                   <a:srgbClr val="DFE8FF"/>
                 </a:solidFill>
@@ -5934,7 +5936,7 @@
               <a:spcAft>
                 <a:spcPts val="100"/>
               </a:spcAft>
-              <a:defRPr sz="1250">
+              <a:defRPr sz="1050">
                 <a:solidFill>
                   <a:srgbClr val="DFE8FF"/>
                 </a:solidFill>
@@ -6199,7 +6201,7 @@
           <a:bodyPr rtlCol="0" anchor="ctr" wrap="square" lIns="228600" tIns="164592"/>
           <a:lstStyle/>
           <a:p>
-            <a:pPr algn="ctr">
+            <a:pPr>
               <a:spcAft>
                 <a:spcPts val="100"/>
               </a:spcAft>
@@ -6740,7 +6742,7 @@
           <a:bodyPr rtlCol="0" anchor="ctr" wrap="square" lIns="228600" tIns="164592"/>
           <a:lstStyle/>
           <a:p>
-            <a:pPr algn="ctr">
+            <a:pPr>
               <a:spcAft>
                 <a:spcPts val="100"/>
               </a:spcAft>
@@ -7185,7 +7187,7 @@
           <a:bodyPr rtlCol="0" anchor="ctr" wrap="square" lIns="228600" tIns="164592"/>
           <a:lstStyle/>
           <a:p>
-            <a:pPr algn="ctr">
+            <a:pPr>
               <a:spcAft>
                 <a:spcPts val="100"/>
               </a:spcAft>
@@ -9121,8 +9123,7 @@
                 <a:tableStyleId>{5C22544A-7EE6-4342-B048-85BDC9FD1C3A}</a:tableStyleId>
               </a:tblPr>
               <a:tblGrid>
-                <a:gridCol w="5486400"/>
-                <a:gridCol w="2926080"/>
+                <a:gridCol w="8412480"/>
                 <a:gridCol w="2770632"/>
               </a:tblGrid>
               <a:tr h="457200">
@@ -9141,26 +9142,6 @@
                       <a:r>
                         <a:t>Integrante do Grupo 5</a:t>
                       </a:r>
-                    </a:p>
-                  </a:txBody>
-                  <a:tcPr>
-                    <a:solidFill>
-                      <a:srgbClr val="39D98A"/>
-                    </a:solidFill>
-                  </a:tcPr>
-                </a:tc>
-                <a:tc>
-                  <a:txBody>
-                    <a:bodyPr/>
-                    <a:lstStyle/>
-                    <a:p>
-                      <a:pPr>
-                        <a:defRPr b="1" sz="1500">
-                          <a:solidFill>
-                            <a:srgbClr val="052012"/>
-                          </a:solidFill>
-                        </a:defRPr>
-                      </a:pPr>
                     </a:p>
                   </a:txBody>
                   <a:tcPr>
@@ -9229,26 +9210,6 @@
                           </a:solidFill>
                         </a:defRPr>
                       </a:pPr>
-                    </a:p>
-                  </a:txBody>
-                  <a:tcPr>
-                    <a:solidFill>
-                      <a:srgbClr val="0A1426"/>
-                    </a:solidFill>
-                  </a:tcPr>
-                </a:tc>
-                <a:tc>
-                  <a:txBody>
-                    <a:bodyPr/>
-                    <a:lstStyle/>
-                    <a:p>
-                      <a:pPr>
-                        <a:defRPr sz="1350">
-                          <a:solidFill>
-                            <a:srgbClr val="F7FAFF"/>
-                          </a:solidFill>
-                        </a:defRPr>
-                      </a:pPr>
                       <a:r>
                         <a:t>32513480</a:t>
                       </a:r>
@@ -9277,26 +9238,6 @@
                       <a:r>
                         <a:t>Rafael Luiz Ferreira de Souza</a:t>
                       </a:r>
-                    </a:p>
-                  </a:txBody>
-                  <a:tcPr>
-                    <a:solidFill>
-                      <a:srgbClr val="0D1830"/>
-                    </a:solidFill>
-                  </a:tcPr>
-                </a:tc>
-                <a:tc>
-                  <a:txBody>
-                    <a:bodyPr/>
-                    <a:lstStyle/>
-                    <a:p>
-                      <a:pPr>
-                        <a:defRPr sz="1350">
-                          <a:solidFill>
-                            <a:srgbClr val="F7FAFF"/>
-                          </a:solidFill>
-                        </a:defRPr>
-                      </a:pPr>
                     </a:p>
                   </a:txBody>
                   <a:tcPr>
@@ -9365,26 +9306,6 @@
                           </a:solidFill>
                         </a:defRPr>
                       </a:pPr>
-                    </a:p>
-                  </a:txBody>
-                  <a:tcPr>
-                    <a:solidFill>
-                      <a:srgbClr val="0A1426"/>
-                    </a:solidFill>
-                  </a:tcPr>
-                </a:tc>
-                <a:tc>
-                  <a:txBody>
-                    <a:bodyPr/>
-                    <a:lstStyle/>
-                    <a:p>
-                      <a:pPr>
-                        <a:defRPr sz="1350">
-                          <a:solidFill>
-                            <a:srgbClr val="F7FAFF"/>
-                          </a:solidFill>
-                        </a:defRPr>
-                      </a:pPr>
                       <a:r>
                         <a:t>32515280</a:t>
                       </a:r>
@@ -9433,26 +9354,6 @@
                           </a:solidFill>
                         </a:defRPr>
                       </a:pPr>
-                    </a:p>
-                  </a:txBody>
-                  <a:tcPr>
-                    <a:solidFill>
-                      <a:srgbClr val="0D1830"/>
-                    </a:solidFill>
-                  </a:tcPr>
-                </a:tc>
-                <a:tc>
-                  <a:txBody>
-                    <a:bodyPr/>
-                    <a:lstStyle/>
-                    <a:p>
-                      <a:pPr>
-                        <a:defRPr sz="1350">
-                          <a:solidFill>
-                            <a:srgbClr val="F7FAFF"/>
-                          </a:solidFill>
-                        </a:defRPr>
-                      </a:pPr>
                       <a:r>
                         <a:t>325141430</a:t>
                       </a:r>
@@ -9481,26 +9382,6 @@
                       <a:r>
                         <a:t>Pedro Henrique Martins</a:t>
                       </a:r>
-                    </a:p>
-                  </a:txBody>
-                  <a:tcPr>
-                    <a:solidFill>
-                      <a:srgbClr val="0A1426"/>
-                    </a:solidFill>
-                  </a:tcPr>
-                </a:tc>
-                <a:tc>
-                  <a:txBody>
-                    <a:bodyPr/>
-                    <a:lstStyle/>
-                    <a:p>
-                      <a:pPr>
-                        <a:defRPr sz="1350">
-                          <a:solidFill>
-                            <a:srgbClr val="F7FAFF"/>
-                          </a:solidFill>
-                        </a:defRPr>
-                      </a:pPr>
                     </a:p>
                   </a:txBody>
                   <a:tcPr>

</xml_diff>